<commit_message>
Add uniform colorbar comparison and ablation table
</commit_message>
<xml_diff>
--- a/探地雷达_背景抑制与AGC改进_汇报_2026-03-02.pptx
+++ b/探地雷达_背景抑制与AGC改进_汇报_2026-03-02.pptx
@@ -15,6 +15,8 @@
     <p:sldId id="260" r:id="rId12"/>
     <p:sldId id="261" r:id="rId13"/>
     <p:sldId id="262" r:id="rId14"/>
+    <p:sldId id="263" r:id="rId15"/>
+    <p:sldId id="264" r:id="rId16"/>
   </p:sldIdLst>
   <p:sldSz cx="12192000" cy="6858000"/>
   <p:notesSz cx="6858000" cy="9144000"/>
@@ -4177,6 +4179,557 @@
             </a:pPr>
             <a:r>
               <a:t>下一步：完善消融（无AGC/不同窗/不同背景抑制）+ 指标表。</a:t>
+            </a:r>
+          </a:p>
+        </p:txBody>
+      </p:sp>
+    </p:spTree>
+  </p:cSld>
+  <p:clrMapOvr>
+    <a:masterClrMapping/>
+  </p:clrMapOvr>
+</p:sld>
+</file>
+
+<file path=ppt/slides/slide8.xml><?xml version="1.0" encoding="utf-8"?>
+<p:sld xmlns:a="http://schemas.openxmlformats.org/drawingml/2006/main" xmlns:p="http://schemas.openxmlformats.org/presentationml/2006/main" xmlns:r="http://schemas.openxmlformats.org/officeDocument/2006/relationships">
+  <p:cSld>
+    <p:spTree>
+      <p:nvGrpSpPr>
+        <p:cNvPr id="1" name=""/>
+        <p:cNvGrpSpPr/>
+        <p:nvPr/>
+      </p:nvGrpSpPr>
+      <p:grpSpPr/>
+      <p:sp>
+        <p:nvSpPr>
+          <p:cNvPr id="2" name="Title 1"/>
+          <p:cNvSpPr>
+            <a:spLocks noGrp="1"/>
+          </p:cNvSpPr>
+          <p:nvPr>
+            <p:ph type="title"/>
+          </p:nvPr>
+        </p:nvSpPr>
+        <p:spPr/>
+        <p:txBody>
+          <a:bodyPr/>
+          <a:lstStyle/>
+          <a:p>
+            <a:r>
+              <a:t>统一色标对比图</a:t>
+            </a:r>
+          </a:p>
+        </p:txBody>
+      </p:sp>
+      <p:pic>
+        <p:nvPicPr>
+          <p:cNvPr id="3" name="Picture 2" descr="统一色标_baseline.png"/>
+          <p:cNvPicPr>
+            <a:picLocks noChangeAspect="1"/>
+          </p:cNvPicPr>
+          <p:nvPr/>
+        </p:nvPicPr>
+        <p:blipFill>
+          <a:blip r:embed="rId2"/>
+          <a:stretch>
+            <a:fillRect/>
+          </a:stretch>
+        </p:blipFill>
+        <p:spPr>
+          <a:xfrm>
+            <a:off x="365760" y="1280160"/>
+            <a:ext cx="2926080" cy="1463040"/>
+          </a:xfrm>
+          <a:prstGeom prst="rect">
+            <a:avLst/>
+          </a:prstGeom>
+        </p:spPr>
+      </p:pic>
+      <p:sp>
+        <p:nvSpPr>
+          <p:cNvPr id="4" name="TextBox 3"/>
+          <p:cNvSpPr txBox="1"/>
+          <p:nvPr/>
+        </p:nvSpPr>
+        <p:spPr>
+          <a:xfrm>
+            <a:off x="365760" y="2834640"/>
+            <a:ext cx="2926080" cy="274320"/>
+          </a:xfrm>
+          <a:prstGeom prst="rect">
+            <a:avLst/>
+          </a:prstGeom>
+          <a:noFill/>
+        </p:spPr>
+        <p:txBody>
+          <a:bodyPr wrap="none">
+            <a:spAutoFit/>
+          </a:bodyPr>
+          <a:lstStyle/>
+          <a:p>
+            <a:pPr algn="ctr">
+              <a:defRPr sz="1400"/>
+            </a:pPr>
+            <a:r>
+              <a:t>Baseline</a:t>
+            </a:r>
+          </a:p>
+        </p:txBody>
+      </p:sp>
+      <p:pic>
+        <p:nvPicPr>
+          <p:cNvPr id="5" name="Picture 4" descr="统一色标_svd.png"/>
+          <p:cNvPicPr>
+            <a:picLocks noChangeAspect="1"/>
+          </p:cNvPicPr>
+          <p:nvPr/>
+        </p:nvPicPr>
+        <p:blipFill>
+          <a:blip r:embed="rId3"/>
+          <a:stretch>
+            <a:fillRect/>
+          </a:stretch>
+        </p:blipFill>
+        <p:spPr>
+          <a:xfrm>
+            <a:off x="3657600" y="1280160"/>
+            <a:ext cx="2926080" cy="1463040"/>
+          </a:xfrm>
+          <a:prstGeom prst="rect">
+            <a:avLst/>
+          </a:prstGeom>
+        </p:spPr>
+      </p:pic>
+      <p:sp>
+        <p:nvSpPr>
+          <p:cNvPr id="6" name="TextBox 5"/>
+          <p:cNvSpPr txBox="1"/>
+          <p:nvPr/>
+        </p:nvSpPr>
+        <p:spPr>
+          <a:xfrm>
+            <a:off x="3657600" y="2834640"/>
+            <a:ext cx="2926080" cy="274320"/>
+          </a:xfrm>
+          <a:prstGeom prst="rect">
+            <a:avLst/>
+          </a:prstGeom>
+          <a:noFill/>
+        </p:spPr>
+        <p:txBody>
+          <a:bodyPr wrap="none">
+            <a:spAutoFit/>
+          </a:bodyPr>
+          <a:lstStyle/>
+          <a:p>
+            <a:pPr algn="ctr">
+              <a:defRPr sz="1400"/>
+            </a:pPr>
+            <a:r>
+              <a:t>SVD背景抑制</a:t>
+            </a:r>
+          </a:p>
+        </p:txBody>
+      </p:sp>
+      <p:pic>
+        <p:nvPicPr>
+          <p:cNvPr id="7" name="Picture 6" descr="统一色标_agc.png"/>
+          <p:cNvPicPr>
+            <a:picLocks noChangeAspect="1"/>
+          </p:cNvPicPr>
+          <p:nvPr/>
+        </p:nvPicPr>
+        <p:blipFill>
+          <a:blip r:embed="rId4"/>
+          <a:stretch>
+            <a:fillRect/>
+          </a:stretch>
+        </p:blipFill>
+        <p:spPr>
+          <a:xfrm>
+            <a:off x="6949440" y="1280160"/>
+            <a:ext cx="2926080" cy="1463040"/>
+          </a:xfrm>
+          <a:prstGeom prst="rect">
+            <a:avLst/>
+          </a:prstGeom>
+        </p:spPr>
+      </p:pic>
+      <p:sp>
+        <p:nvSpPr>
+          <p:cNvPr id="8" name="TextBox 7"/>
+          <p:cNvSpPr txBox="1"/>
+          <p:nvPr/>
+        </p:nvSpPr>
+        <p:spPr>
+          <a:xfrm>
+            <a:off x="6949440" y="2834640"/>
+            <a:ext cx="2926080" cy="274320"/>
+          </a:xfrm>
+          <a:prstGeom prst="rect">
+            <a:avLst/>
+          </a:prstGeom>
+          <a:noFill/>
+        </p:spPr>
+        <p:txBody>
+          <a:bodyPr wrap="none">
+            <a:spAutoFit/>
+          </a:bodyPr>
+          <a:lstStyle/>
+          <a:p>
+            <a:pPr algn="ctr">
+              <a:defRPr sz="1400"/>
+            </a:pPr>
+            <a:r>
+              <a:t>AGC改进</a:t>
+            </a:r>
+          </a:p>
+        </p:txBody>
+      </p:sp>
+    </p:spTree>
+  </p:cSld>
+  <p:clrMapOvr>
+    <a:masterClrMapping/>
+  </p:clrMapOvr>
+</p:sld>
+</file>
+
+<file path=ppt/slides/slide9.xml><?xml version="1.0" encoding="utf-8"?>
+<p:sld xmlns:a="http://schemas.openxmlformats.org/drawingml/2006/main" xmlns:p="http://schemas.openxmlformats.org/presentationml/2006/main" xmlns:r="http://schemas.openxmlformats.org/officeDocument/2006/relationships">
+  <p:cSld>
+    <p:spTree>
+      <p:nvGrpSpPr>
+        <p:cNvPr id="1" name=""/>
+        <p:cNvGrpSpPr/>
+        <p:nvPr/>
+      </p:nvGrpSpPr>
+      <p:grpSpPr/>
+      <p:sp>
+        <p:nvSpPr>
+          <p:cNvPr id="2" name="Title 1"/>
+          <p:cNvSpPr>
+            <a:spLocks noGrp="1"/>
+          </p:cNvSpPr>
+          <p:nvPr>
+            <p:ph type="title"/>
+          </p:nvPr>
+        </p:nvSpPr>
+        <p:spPr/>
+        <p:txBody>
+          <a:bodyPr/>
+          <a:lstStyle/>
+          <a:p>
+            <a:r>
+              <a:t>消融指标表</a:t>
+            </a:r>
+          </a:p>
+        </p:txBody>
+      </p:sp>
+      <p:graphicFrame>
+        <p:nvGraphicFramePr>
+          <p:cNvPr id="3" name="Table 2"/>
+          <p:cNvGraphicFramePr>
+            <a:graphicFrameLocks noGrp="1"/>
+          </p:cNvGraphicFramePr>
+          <p:nvPr/>
+        </p:nvGraphicFramePr>
+        <p:xfrm>
+          <a:off x="457200" y="1463040"/>
+          <a:ext cx="8229600" cy="3200400"/>
+        </p:xfrm>
+        <a:graphic>
+          <a:graphicData uri="http://schemas.openxmlformats.org/drawingml/2006/table">
+            <a:tbl>
+              <a:tblPr firstRow="1" bandRow="1">
+                <a:tableStyleId>{5C22544A-7EE6-4342-B048-85BDC9FD1C3A}</a:tableStyleId>
+              </a:tblPr>
+              <a:tblGrid>
+                <a:gridCol w="1645920"/>
+                <a:gridCol w="1645920"/>
+                <a:gridCol w="1645920"/>
+                <a:gridCol w="1645920"/>
+                <a:gridCol w="1645920"/>
+              </a:tblGrid>
+              <a:tr h="800100">
+                <a:tc>
+                  <a:txBody>
+                    <a:bodyPr/>
+                    <a:lstStyle/>
+                    <a:p>
+                      <a:r>
+                        <a:t>方法</a:t>
+                      </a:r>
+                    </a:p>
+                  </a:txBody>
+                  <a:tcPr/>
+                </a:tc>
+                <a:tc>
+                  <a:txBody>
+                    <a:bodyPr/>
+                    <a:lstStyle/>
+                    <a:p>
+                      <a:r>
+                        <a:t>SNR提升</a:t>
+                      </a:r>
+                    </a:p>
+                  </a:txBody>
+                  <a:tcPr/>
+                </a:tc>
+                <a:tc>
+                  <a:txBody>
+                    <a:bodyPr/>
+                    <a:lstStyle/>
+                    <a:p>
+                      <a:r>
+                        <a:t>对比度</a:t>
+                      </a:r>
+                    </a:p>
+                  </a:txBody>
+                  <a:tcPr/>
+                </a:tc>
+                <a:tc>
+                  <a:txBody>
+                    <a:bodyPr/>
+                    <a:lstStyle/>
+                    <a:p>
+                      <a:r>
+                        <a:t>结构保真</a:t>
+                      </a:r>
+                    </a:p>
+                  </a:txBody>
+                  <a:tcPr/>
+                </a:tc>
+                <a:tc>
+                  <a:txBody>
+                    <a:bodyPr/>
+                    <a:lstStyle/>
+                    <a:p>
+                      <a:r>
+                        <a:t>运行耗时</a:t>
+                      </a:r>
+                    </a:p>
+                  </a:txBody>
+                  <a:tcPr/>
+                </a:tc>
+              </a:tr>
+              <a:tr h="800100">
+                <a:tc>
+                  <a:txBody>
+                    <a:bodyPr/>
+                    <a:lstStyle/>
+                    <a:p>
+                      <a:r>
+                        <a:t>Baseline</a:t>
+                      </a:r>
+                    </a:p>
+                  </a:txBody>
+                  <a:tcPr/>
+                </a:tc>
+                <a:tc>
+                  <a:txBody>
+                    <a:bodyPr/>
+                    <a:lstStyle/>
+                    <a:p>
+                      <a:r>
+                        <a:t>占位(待补充)</a:t>
+                      </a:r>
+                    </a:p>
+                  </a:txBody>
+                  <a:tcPr/>
+                </a:tc>
+                <a:tc>
+                  <a:txBody>
+                    <a:bodyPr/>
+                    <a:lstStyle/>
+                    <a:p>
+                      <a:r>
+                        <a:t>占位(待补充)</a:t>
+                      </a:r>
+                    </a:p>
+                  </a:txBody>
+                  <a:tcPr/>
+                </a:tc>
+                <a:tc>
+                  <a:txBody>
+                    <a:bodyPr/>
+                    <a:lstStyle/>
+                    <a:p>
+                      <a:r>
+                        <a:t>占位(待补充)</a:t>
+                      </a:r>
+                    </a:p>
+                  </a:txBody>
+                  <a:tcPr/>
+                </a:tc>
+                <a:tc>
+                  <a:txBody>
+                    <a:bodyPr/>
+                    <a:lstStyle/>
+                    <a:p>
+                      <a:r>
+                        <a:t>占位(待补充)</a:t>
+                      </a:r>
+                    </a:p>
+                  </a:txBody>
+                  <a:tcPr/>
+                </a:tc>
+              </a:tr>
+              <a:tr h="800100">
+                <a:tc>
+                  <a:txBody>
+                    <a:bodyPr/>
+                    <a:lstStyle/>
+                    <a:p>
+                      <a:r>
+                        <a:t>SVD背景抑制</a:t>
+                      </a:r>
+                    </a:p>
+                  </a:txBody>
+                  <a:tcPr/>
+                </a:tc>
+                <a:tc>
+                  <a:txBody>
+                    <a:bodyPr/>
+                    <a:lstStyle/>
+                    <a:p>
+                      <a:r>
+                        <a:t>占位(待补充)</a:t>
+                      </a:r>
+                    </a:p>
+                  </a:txBody>
+                  <a:tcPr/>
+                </a:tc>
+                <a:tc>
+                  <a:txBody>
+                    <a:bodyPr/>
+                    <a:lstStyle/>
+                    <a:p>
+                      <a:r>
+                        <a:t>占位(待补充)</a:t>
+                      </a:r>
+                    </a:p>
+                  </a:txBody>
+                  <a:tcPr/>
+                </a:tc>
+                <a:tc>
+                  <a:txBody>
+                    <a:bodyPr/>
+                    <a:lstStyle/>
+                    <a:p>
+                      <a:r>
+                        <a:t>占位(待补充)</a:t>
+                      </a:r>
+                    </a:p>
+                  </a:txBody>
+                  <a:tcPr/>
+                </a:tc>
+                <a:tc>
+                  <a:txBody>
+                    <a:bodyPr/>
+                    <a:lstStyle/>
+                    <a:p>
+                      <a:r>
+                        <a:t>占位(待补充)</a:t>
+                      </a:r>
+                    </a:p>
+                  </a:txBody>
+                  <a:tcPr/>
+                </a:tc>
+              </a:tr>
+              <a:tr h="800100">
+                <a:tc>
+                  <a:txBody>
+                    <a:bodyPr/>
+                    <a:lstStyle/>
+                    <a:p>
+                      <a:r>
+                        <a:t>AGC改进</a:t>
+                      </a:r>
+                    </a:p>
+                  </a:txBody>
+                  <a:tcPr/>
+                </a:tc>
+                <a:tc>
+                  <a:txBody>
+                    <a:bodyPr/>
+                    <a:lstStyle/>
+                    <a:p>
+                      <a:r>
+                        <a:t>占位(待补充)</a:t>
+                      </a:r>
+                    </a:p>
+                  </a:txBody>
+                  <a:tcPr/>
+                </a:tc>
+                <a:tc>
+                  <a:txBody>
+                    <a:bodyPr/>
+                    <a:lstStyle/>
+                    <a:p>
+                      <a:r>
+                        <a:t>占位(待补充)</a:t>
+                      </a:r>
+                    </a:p>
+                  </a:txBody>
+                  <a:tcPr/>
+                </a:tc>
+                <a:tc>
+                  <a:txBody>
+                    <a:bodyPr/>
+                    <a:lstStyle/>
+                    <a:p>
+                      <a:r>
+                        <a:t>占位(待补充)</a:t>
+                      </a:r>
+                    </a:p>
+                  </a:txBody>
+                  <a:tcPr/>
+                </a:tc>
+                <a:tc>
+                  <a:txBody>
+                    <a:bodyPr/>
+                    <a:lstStyle/>
+                    <a:p>
+                      <a:r>
+                        <a:t>占位(待补充)</a:t>
+                      </a:r>
+                    </a:p>
+                  </a:txBody>
+                  <a:tcPr/>
+                </a:tc>
+              </a:tr>
+            </a:tbl>
+          </a:graphicData>
+        </a:graphic>
+      </p:graphicFrame>
+      <p:sp>
+        <p:nvSpPr>
+          <p:cNvPr id="4" name="TextBox 3"/>
+          <p:cNvSpPr txBox="1"/>
+          <p:nvPr/>
+        </p:nvSpPr>
+        <p:spPr>
+          <a:xfrm>
+            <a:off x="457200" y="4754880"/>
+            <a:ext cx="8229600" cy="457200"/>
+          </a:xfrm>
+          <a:prstGeom prst="rect">
+            <a:avLst/>
+          </a:prstGeom>
+          <a:noFill/>
+        </p:spPr>
+        <p:txBody>
+          <a:bodyPr wrap="none">
+            <a:spAutoFit/>
+          </a:bodyPr>
+          <a:lstStyle/>
+          <a:p>
+            <a:pPr>
+              <a:defRPr sz="1200"/>
+            </a:pPr>
+            <a:r>
+              <a:t>注：指标数值待补充或引用已有实验记录来源。</a:t>
             </a:r>
           </a:p>
         </p:txBody>

</xml_diff>